<commit_message>
improve lectures 02 and 03
</commit_message>
<xml_diff>
--- a/Lectures/01.Foundations/Lecture03.pptx
+++ b/Lectures/01.Foundations/Lecture03.pptx
@@ -31,13 +31,13 @@
     <p:sldId id="1053" r:id="rId19"/>
     <p:sldId id="1047" r:id="rId20"/>
     <p:sldId id="1033" r:id="rId21"/>
-    <p:sldId id="1048" r:id="rId22"/>
-    <p:sldId id="1018" r:id="rId23"/>
-    <p:sldId id="1050" r:id="rId24"/>
-    <p:sldId id="1051" r:id="rId25"/>
-    <p:sldId id="1052" r:id="rId26"/>
-    <p:sldId id="1056" r:id="rId27"/>
-    <p:sldId id="1042" r:id="rId28"/>
+    <p:sldId id="1042" r:id="rId22"/>
+    <p:sldId id="1048" r:id="rId23"/>
+    <p:sldId id="1018" r:id="rId24"/>
+    <p:sldId id="1050" r:id="rId25"/>
+    <p:sldId id="1051" r:id="rId26"/>
+    <p:sldId id="1052" r:id="rId27"/>
+    <p:sldId id="1056" r:id="rId28"/>
   </p:sldIdLst>
   <p:sldSz cx="9144000" cy="6858000" type="letter"/>
   <p:notesSz cx="9601200" cy="7315200"/>
@@ -4735,8 +4735,8 @@
           <a:chExt cx="0" cy="0"/>
         </a:xfrm>
       </p:grpSpPr>
-      <mc:AlternateContent xmlns:mc="http://schemas.openxmlformats.org/markup-compatibility/2006" xmlns:a14="http://schemas.microsoft.com/office/drawing/2010/main">
-        <mc:Choice Requires="a14">
+      <mc:AlternateContent xmlns:mc="http://schemas.openxmlformats.org/markup-compatibility/2006">
+        <mc:Choice xmlns:a14="http://schemas.microsoft.com/office/drawing/2010/main" Requires="a14">
           <p:sp>
             <p:nvSpPr>
               <p:cNvPr id="4" name="Content Placeholder 3">
@@ -4911,74 +4911,6 @@
                   <a:rPr lang="en-US" dirty="0"/>
                   <a:t>? </a:t>
                 </a:r>
-              </a:p>
-              <a:p>
-                <a:pPr marL="0" indent="0">
-                  <a:buNone/>
-                </a:pPr>
-                <a:endParaRPr lang="en-US" dirty="0"/>
-              </a:p>
-              <a:p>
-                <a:pPr marL="0" indent="0">
-                  <a:buNone/>
-                </a:pPr>
-                <a:r>
-                  <a:rPr lang="en-US" dirty="0"/>
-                  <a:t>However, as shown on the next slide, </a:t>
-                </a:r>
-                <a14:m>
-                  <m:oMath xmlns:m="http://schemas.openxmlformats.org/officeDocument/2006/math">
-                    <m:r>
-                      <a:rPr lang="en-US" b="0" i="1" smtClean="0">
-                        <a:solidFill>
-                          <a:srgbClr val="0033CC"/>
-                        </a:solidFill>
-                        <a:latin typeface="Cambria Math" panose="02040503050406030204" pitchFamily="18" charset="0"/>
-                      </a:rPr>
-                      <m:t>𝑝</m:t>
-                    </m:r>
-                    <m:r>
-                      <a:rPr lang="en-US" b="0" i="1" smtClean="0">
-                        <a:solidFill>
-                          <a:srgbClr val="0033CC"/>
-                        </a:solidFill>
-                        <a:latin typeface="Cambria Math" panose="02040503050406030204" pitchFamily="18" charset="0"/>
-                      </a:rPr>
-                      <m:t>(1|</m:t>
-                    </m:r>
-                    <m:r>
-                      <a:rPr lang="en-US" b="0" i="1" smtClean="0">
-                        <a:solidFill>
-                          <a:srgbClr val="0033CC"/>
-                        </a:solidFill>
-                        <a:latin typeface="Cambria Math" panose="02040503050406030204" pitchFamily="18" charset="0"/>
-                      </a:rPr>
-                      <m:t>𝑥</m:t>
-                    </m:r>
-                    <m:r>
-                      <a:rPr lang="en-US" b="0" i="1" smtClean="0">
-                        <a:solidFill>
-                          <a:srgbClr val="0033CC"/>
-                        </a:solidFill>
-                        <a:latin typeface="Cambria Math" panose="02040503050406030204" pitchFamily="18" charset="0"/>
-                      </a:rPr>
-                      <m:t>)</m:t>
-                    </m:r>
-                  </m:oMath>
-                </a14:m>
-                <a:r>
-                  <a:rPr lang="en-US" dirty="0">
-                    <a:solidFill>
-                      <a:srgbClr val="0033CC"/>
-                    </a:solidFill>
-                    <a:effectLst>
-                      <a:outerShdw blurRad="38100" dist="38100" dir="2700000" algn="tl">
-                        <a:srgbClr val="DDDDDD"/>
-                      </a:outerShdw>
-                    </a:effectLst>
-                  </a:rPr>
-                  <a:t> </a:t>
-                </a:r>
                 <a:r>
                   <a:rPr lang="en-US" dirty="0">
                     <a:effectLst>
@@ -4987,7 +4919,7 @@
                       </a:outerShdw>
                     </a:effectLst>
                   </a:rPr>
-                  <a:t>can be computed from a model trained with a balanced dataset.</a:t>
+                  <a:t>.</a:t>
                 </a:r>
                 <a:br>
                   <a:rPr lang="en-US" dirty="0">
@@ -5003,7 +4935,7 @@
             </p:txBody>
           </p:sp>
         </mc:Choice>
-        <mc:Fallback xmlns="">
+        <mc:Fallback>
           <p:sp>
             <p:nvSpPr>
               <p:cNvPr id="4" name="Content Placeholder 3">
@@ -5112,8 +5044,8 @@
           <a:chExt cx="0" cy="0"/>
         </a:xfrm>
       </p:grpSpPr>
-      <mc:AlternateContent xmlns:mc="http://schemas.openxmlformats.org/markup-compatibility/2006" xmlns:a14="http://schemas.microsoft.com/office/drawing/2010/main">
-        <mc:Choice Requires="a14">
+      <mc:AlternateContent xmlns:mc="http://schemas.openxmlformats.org/markup-compatibility/2006">
+        <mc:Choice xmlns:a14="http://schemas.microsoft.com/office/drawing/2010/main" Requires="a14">
           <p:sp>
             <p:nvSpPr>
               <p:cNvPr id="4" name="Content Placeholder 3">
@@ -5768,13 +5700,100 @@
                 </a:pPr>
                 <a:r>
                   <a:rPr lang="en-US" dirty="0"/>
-                  <a:t>So, it is not necessary to use the true priors during training.</a:t>
+                  <a:t>This shows that, </a:t>
+                </a:r>
+                <a14:m>
+                  <m:oMath xmlns:m="http://schemas.openxmlformats.org/officeDocument/2006/math">
+                    <m:r>
+                      <a:rPr lang="en-US" i="1">
+                        <a:solidFill>
+                          <a:srgbClr val="0033CC"/>
+                        </a:solidFill>
+                        <a:latin typeface="Cambria Math" panose="02040503050406030204" pitchFamily="18" charset="0"/>
+                      </a:rPr>
+                      <m:t>𝑝</m:t>
+                    </m:r>
+                    <m:r>
+                      <a:rPr lang="en-US" i="1">
+                        <a:solidFill>
+                          <a:srgbClr val="0033CC"/>
+                        </a:solidFill>
+                        <a:latin typeface="Cambria Math" panose="02040503050406030204" pitchFamily="18" charset="0"/>
+                      </a:rPr>
+                      <m:t>(1|</m:t>
+                    </m:r>
+                    <m:r>
+                      <a:rPr lang="en-US" i="1">
+                        <a:solidFill>
+                          <a:srgbClr val="0033CC"/>
+                        </a:solidFill>
+                        <a:latin typeface="Cambria Math" panose="02040503050406030204" pitchFamily="18" charset="0"/>
+                      </a:rPr>
+                      <m:t>𝑥</m:t>
+                    </m:r>
+                    <m:r>
+                      <a:rPr lang="en-US" i="1">
+                        <a:solidFill>
+                          <a:srgbClr val="0033CC"/>
+                        </a:solidFill>
+                        <a:latin typeface="Cambria Math" panose="02040503050406030204" pitchFamily="18" charset="0"/>
+                      </a:rPr>
+                      <m:t>)</m:t>
+                    </m:r>
+                  </m:oMath>
+                </a14:m>
+                <a:r>
+                  <a:rPr lang="en-US" dirty="0">
+                    <a:solidFill>
+                      <a:srgbClr val="0033CC"/>
+                    </a:solidFill>
+                    <a:effectLst>
+                      <a:outerShdw blurRad="38100" dist="38100" dir="2700000" algn="tl">
+                        <a:srgbClr val="DDDDDD"/>
+                      </a:outerShdw>
+                    </a:effectLst>
+                  </a:rPr>
+                  <a:t> </a:t>
+                </a:r>
+                <a:r>
+                  <a:rPr lang="en-US" dirty="0">
+                    <a:effectLst>
+                      <a:outerShdw blurRad="38100" dist="38100" dir="2700000" algn="tl">
+                        <a:srgbClr val="DDDDDD"/>
+                      </a:outerShdw>
+                    </a:effectLst>
+                  </a:rPr>
+                  <a:t>can be computed from a model trained with a </a:t>
+                </a:r>
+                <a:r>
+                  <a:rPr lang="en-US" i="1" dirty="0">
+                    <a:effectLst>
+                      <a:outerShdw blurRad="38100" dist="38100" dir="2700000" algn="tl">
+                        <a:srgbClr val="DDDDDD"/>
+                      </a:outerShdw>
+                    </a:effectLst>
+                  </a:rPr>
+                  <a:t>balanced</a:t>
+                </a:r>
+                <a:r>
+                  <a:rPr lang="en-US" dirty="0">
+                    <a:effectLst>
+                      <a:outerShdw blurRad="38100" dist="38100" dir="2700000" algn="tl">
+                        <a:srgbClr val="DDDDDD"/>
+                      </a:outerShdw>
+                    </a:effectLst>
+                  </a:rPr>
+                  <a:t> dataset</a:t>
+                </a:r>
+                <a:r>
+                  <a:rPr lang="en-US" dirty="0"/>
+                  <a:t>.</a:t>
                 </a:r>
               </a:p>
             </p:txBody>
           </p:sp>
         </mc:Choice>
-        <mc:Fallback xmlns="">
+        <mc:Fallback>
           <p:sp>
             <p:nvSpPr>
               <p:cNvPr id="4" name="Content Placeholder 3">
@@ -6135,8 +6154,8 @@
           </a:p>
         </p:txBody>
       </p:sp>
-      <mc:AlternateContent xmlns:mc="http://schemas.openxmlformats.org/markup-compatibility/2006" xmlns:a14="http://schemas.microsoft.com/office/drawing/2010/main">
-        <mc:Choice Requires="a14">
+      <mc:AlternateContent xmlns:mc="http://schemas.openxmlformats.org/markup-compatibility/2006">
+        <mc:Choice xmlns:a14="http://schemas.microsoft.com/office/drawing/2010/main" Requires="a14">
           <p:sp>
             <p:nvSpPr>
               <p:cNvPr id="8" name="Content Placeholder 7">
@@ -6323,7 +6342,7 @@
                 </a14:m>
                 <a:r>
                   <a:rPr lang="en-US" dirty="0"/>
-                  <a:t> to the “positive” (signal) class and below which one assigns it to the “negative” (background) class. </a:t>
+                  <a:t> to the “positive” class and below which one assigns it to the “negative” class. </a:t>
                 </a:r>
                 <a:br>
                   <a:rPr lang="en-US" dirty="0"/>
@@ -6896,7 +6915,7 @@
                         <m:ctrlPr>
                           <a:rPr lang="en-US" b="1" i="1" smtClean="0">
                             <a:solidFill>
-                              <a:srgbClr val="C00000"/>
+                              <a:schemeClr val="tx1"/>
                             </a:solidFill>
                             <a:latin typeface="Cambria Math" panose="02040503050406030204" pitchFamily="18" charset="0"/>
                           </a:rPr>
@@ -7158,7 +7177,7 @@
             </p:txBody>
           </p:sp>
         </mc:Choice>
-        <mc:Fallback xmlns="">
+        <mc:Fallback>
           <p:sp>
             <p:nvSpPr>
               <p:cNvPr id="8" name="Content Placeholder 7">
@@ -7179,7 +7198,7 @@
               <a:blipFill>
                 <a:blip r:embed="rId2"/>
                 <a:stretch>
-                  <a:fillRect l="-1305" t="-1316" r="-1631" b="-7895"/>
+                  <a:fillRect l="-1305" t="-1316" b="-7895"/>
                 </a:stretch>
               </a:blipFill>
             </p:spPr>
@@ -9060,7 +9079,7 @@
                         <m:chr m:val="∑"/>
                         <m:supHide m:val="on"/>
                         <m:ctrlPr>
-                          <a:rPr lang="en-US" i="1">
+                          <a:rPr lang="en-US" b="0" i="1" smtClean="0">
                             <a:latin typeface="Cambria Math" panose="02040503050406030204" pitchFamily="18" charset="0"/>
                           </a:rPr>
                         </m:ctrlPr>
@@ -9221,7 +9240,7 @@
                         <m:chr m:val="∑"/>
                         <m:supHide m:val="on"/>
                         <m:ctrlPr>
-                          <a:rPr lang="en-US" i="1">
+                          <a:rPr lang="en-US" b="0" i="1" smtClean="0">
                             <a:latin typeface="Cambria Math" panose="02040503050406030204" pitchFamily="18" charset="0"/>
                           </a:rPr>
                         </m:ctrlPr>
@@ -10821,8 +10840,8 @@
           </a:p>
         </p:txBody>
       </p:sp>
-      <mc:AlternateContent xmlns:mc="http://schemas.openxmlformats.org/markup-compatibility/2006">
-        <mc:Choice xmlns:a14="http://schemas.microsoft.com/office/drawing/2010/main" Requires="a14">
+      <mc:AlternateContent xmlns:mc="http://schemas.openxmlformats.org/markup-compatibility/2006" xmlns:a14="http://schemas.microsoft.com/office/drawing/2010/main">
+        <mc:Choice Requires="a14">
           <p:sp>
             <p:nvSpPr>
               <p:cNvPr id="8" name="Content Placeholder 7">
@@ -11383,7 +11402,7 @@
             </p:txBody>
           </p:sp>
         </mc:Choice>
-        <mc:Fallback>
+        <mc:Fallback xmlns="">
           <p:sp>
             <p:nvSpPr>
               <p:cNvPr id="8" name="Content Placeholder 7">
@@ -11490,6 +11509,133 @@
   <p:cSld>
     <p:spTree>
       <p:nvGrpSpPr>
+        <p:cNvPr id="1" name=""/>
+        <p:cNvGrpSpPr/>
+        <p:nvPr/>
+      </p:nvGrpSpPr>
+      <p:grpSpPr>
+        <a:xfrm>
+          <a:off x="0" y="0"/>
+          <a:ext cx="0" cy="0"/>
+          <a:chOff x="0" y="0"/>
+          <a:chExt cx="0" cy="0"/>
+        </a:xfrm>
+      </p:grpSpPr>
+      <p:sp>
+        <p:nvSpPr>
+          <p:cNvPr id="3" name="Content Placeholder 2">
+            <a:extLst>
+              <a:ext uri="{FF2B5EF4-FFF2-40B4-BE49-F238E27FC236}">
+                <a16:creationId xmlns:a16="http://schemas.microsoft.com/office/drawing/2014/main" id="{DCA0730A-77BF-1B8D-5376-F6DCE604B7BB}"/>
+              </a:ext>
+            </a:extLst>
+          </p:cNvPr>
+          <p:cNvSpPr>
+            <a:spLocks noGrp="1"/>
+          </p:cNvSpPr>
+          <p:nvPr>
+            <p:ph sz="half" idx="1"/>
+          </p:nvPr>
+        </p:nvSpPr>
+        <p:spPr/>
+        <p:txBody>
+          <a:bodyPr/>
+          <a:lstStyle/>
+          <a:p>
+            <a:r>
+              <a:rPr lang="en-US" dirty="0"/>
+              <a:t>In addition to the ROC curve and the AUC, the performance of a classifier can be characterized with several other numbers including:</a:t>
+            </a:r>
+          </a:p>
+          <a:p>
+            <a:pPr lvl="1"/>
+            <a:r>
+              <a:rPr lang="en-US" dirty="0"/>
+              <a:t>False Negatives (FN)</a:t>
+            </a:r>
+          </a:p>
+          <a:p>
+            <a:pPr lvl="1"/>
+            <a:r>
+              <a:rPr lang="en-US" dirty="0"/>
+              <a:t>True Positives	(TP)</a:t>
+            </a:r>
+          </a:p>
+          <a:p>
+            <a:pPr lvl="1"/>
+            <a:r>
+              <a:rPr lang="en-US" dirty="0"/>
+              <a:t>True Negatives 	(TN)</a:t>
+            </a:r>
+          </a:p>
+          <a:p>
+            <a:pPr lvl="1"/>
+            <a:r>
+              <a:rPr lang="en-US" dirty="0"/>
+              <a:t>False Positives	(FP)</a:t>
+            </a:r>
+          </a:p>
+          <a:p>
+            <a:pPr marL="457200" lvl="1" indent="0">
+              <a:buNone/>
+            </a:pPr>
+            <a:r>
+              <a:rPr lang="en-US" dirty="0"/>
+              <a:t>which can be represented in a confusion matrix.</a:t>
+            </a:r>
+            <a:br>
+              <a:rPr lang="en-US" dirty="0"/>
+            </a:br>
+            <a:endParaRPr lang="en-US" dirty="0"/>
+          </a:p>
+        </p:txBody>
+      </p:sp>
+      <p:sp>
+        <p:nvSpPr>
+          <p:cNvPr id="2" name="Title 1">
+            <a:extLst>
+              <a:ext uri="{FF2B5EF4-FFF2-40B4-BE49-F238E27FC236}">
+                <a16:creationId xmlns:a16="http://schemas.microsoft.com/office/drawing/2014/main" id="{4B31FE53-CCD3-2FB4-0B9D-BDDBD7ADB3B9}"/>
+              </a:ext>
+            </a:extLst>
+          </p:cNvPr>
+          <p:cNvSpPr>
+            <a:spLocks noGrp="1"/>
+          </p:cNvSpPr>
+          <p:nvPr>
+            <p:ph type="title"/>
+          </p:nvPr>
+        </p:nvSpPr>
+        <p:spPr/>
+        <p:txBody>
+          <a:bodyPr/>
+          <a:lstStyle/>
+          <a:p>
+            <a:r>
+              <a:rPr lang="en-US" dirty="0"/>
+              <a:t>Summary</a:t>
+            </a:r>
+          </a:p>
+        </p:txBody>
+      </p:sp>
+    </p:spTree>
+    <p:extLst>
+      <p:ext uri="{BB962C8B-B14F-4D97-AF65-F5344CB8AC3E}">
+        <p14:creationId xmlns:p14="http://schemas.microsoft.com/office/powerpoint/2010/main" val="1190940371"/>
+      </p:ext>
+    </p:extLst>
+  </p:cSld>
+  <p:clrMapOvr>
+    <a:masterClrMapping/>
+  </p:clrMapOvr>
+</p:sld>
+</file>
+
+<file path=ppt/slides/slide22.xml><?xml version="1.0" encoding="utf-8"?>
+<p:sld xmlns:a="http://schemas.openxmlformats.org/drawingml/2006/main" xmlns:r="http://schemas.openxmlformats.org/officeDocument/2006/relationships" xmlns:p="http://schemas.openxmlformats.org/presentationml/2006/main">
+  <p:cSld>
+    <p:spTree>
+      <p:nvGrpSpPr>
         <p:cNvPr id="1" name="">
           <a:extLst>
             <a:ext uri="{FF2B5EF4-FFF2-40B4-BE49-F238E27FC236}">
@@ -11552,7 +11698,7 @@
 </p:sld>
 </file>
 
-<file path=ppt/slides/slide22.xml><?xml version="1.0" encoding="utf-8"?>
+<file path=ppt/slides/slide23.xml><?xml version="1.0" encoding="utf-8"?>
 <p:sld xmlns:a="http://schemas.openxmlformats.org/drawingml/2006/main" xmlns:r="http://schemas.openxmlformats.org/officeDocument/2006/relationships" xmlns:p="http://schemas.openxmlformats.org/presentationml/2006/main">
   <p:cSld>
     <p:spTree>
@@ -11575,8 +11721,8 @@
           <a:chExt cx="0" cy="0"/>
         </a:xfrm>
       </p:grpSpPr>
-      <mc:AlternateContent xmlns:mc="http://schemas.openxmlformats.org/markup-compatibility/2006">
-        <mc:Choice xmlns:a14="http://schemas.microsoft.com/office/drawing/2010/main" Requires="a14">
+      <mc:AlternateContent xmlns:mc="http://schemas.openxmlformats.org/markup-compatibility/2006" xmlns:a14="http://schemas.microsoft.com/office/drawing/2010/main">
+        <mc:Choice Requires="a14">
           <p:sp>
             <p:nvSpPr>
               <p:cNvPr id="4" name="Content Placeholder 3">
@@ -12199,7 +12345,7 @@
             </p:txBody>
           </p:sp>
         </mc:Choice>
-        <mc:Fallback>
+        <mc:Fallback xmlns="">
           <p:sp>
             <p:nvSpPr>
               <p:cNvPr id="4" name="Content Placeholder 3">
@@ -12285,7 +12431,7 @@
 </p:sld>
 </file>
 
-<file path=ppt/slides/slide23.xml><?xml version="1.0" encoding="utf-8"?>
+<file path=ppt/slides/slide24.xml><?xml version="1.0" encoding="utf-8"?>
 <p:sld xmlns:a="http://schemas.openxmlformats.org/drawingml/2006/main" xmlns:r="http://schemas.openxmlformats.org/officeDocument/2006/relationships" xmlns:p="http://schemas.openxmlformats.org/presentationml/2006/main">
   <p:cSld>
     <p:spTree>
@@ -13515,7 +13661,7 @@
 </p:sld>
 </file>
 
-<file path=ppt/slides/slide24.xml><?xml version="1.0" encoding="utf-8"?>
+<file path=ppt/slides/slide25.xml><?xml version="1.0" encoding="utf-8"?>
 <p:sld xmlns:a="http://schemas.openxmlformats.org/drawingml/2006/main" xmlns:r="http://schemas.openxmlformats.org/officeDocument/2006/relationships" xmlns:p="http://schemas.openxmlformats.org/presentationml/2006/main">
   <p:cSld>
     <p:spTree>
@@ -13571,8 +13717,8 @@
           </a:p>
         </p:txBody>
       </p:sp>
-      <mc:AlternateContent xmlns:mc="http://schemas.openxmlformats.org/markup-compatibility/2006">
-        <mc:Choice xmlns:a14="http://schemas.microsoft.com/office/drawing/2010/main" Requires="a14">
+      <mc:AlternateContent xmlns:mc="http://schemas.openxmlformats.org/markup-compatibility/2006" xmlns:a14="http://schemas.microsoft.com/office/drawing/2010/main">
+        <mc:Choice Requires="a14">
           <p:sp>
             <p:nvSpPr>
               <p:cNvPr id="8" name="Content Placeholder 7">
@@ -14000,7 +14146,7 @@
             </p:txBody>
           </p:sp>
         </mc:Choice>
-        <mc:Fallback>
+        <mc:Fallback xmlns="">
           <p:sp>
             <p:nvSpPr>
               <p:cNvPr id="8" name="Content Placeholder 7">
@@ -14298,7 +14444,7 @@
 </p:sld>
 </file>
 
-<file path=ppt/slides/slide25.xml><?xml version="1.0" encoding="utf-8"?>
+<file path=ppt/slides/slide26.xml><?xml version="1.0" encoding="utf-8"?>
 <p:sld xmlns:a="http://schemas.openxmlformats.org/drawingml/2006/main" xmlns:r="http://schemas.openxmlformats.org/officeDocument/2006/relationships" xmlns:p="http://schemas.openxmlformats.org/presentationml/2006/main">
   <p:cSld>
     <p:spTree>
@@ -15651,7 +15797,7 @@
 </p:sld>
 </file>
 
-<file path=ppt/slides/slide26.xml><?xml version="1.0" encoding="utf-8"?>
+<file path=ppt/slides/slide27.xml><?xml version="1.0" encoding="utf-8"?>
 <p:sld xmlns:a="http://schemas.openxmlformats.org/drawingml/2006/main" xmlns:r="http://schemas.openxmlformats.org/officeDocument/2006/relationships" xmlns:p="http://schemas.openxmlformats.org/presentationml/2006/main">
   <p:cSld>
     <p:spTree>
@@ -15707,8 +15853,8 @@
           </a:p>
         </p:txBody>
       </p:sp>
-      <mc:AlternateContent xmlns:mc="http://schemas.openxmlformats.org/markup-compatibility/2006">
-        <mc:Choice xmlns:a14="http://schemas.microsoft.com/office/drawing/2010/main" Requires="a14">
+      <mc:AlternateContent xmlns:mc="http://schemas.openxmlformats.org/markup-compatibility/2006" xmlns:a14="http://schemas.microsoft.com/office/drawing/2010/main">
+        <mc:Choice Requires="a14">
           <p:sp>
             <p:nvSpPr>
               <p:cNvPr id="8" name="Content Placeholder 7">
@@ -16677,7 +16823,7 @@
             </p:txBody>
           </p:sp>
         </mc:Choice>
-        <mc:Fallback>
+        <mc:Fallback xmlns="">
           <p:sp>
             <p:nvSpPr>
               <p:cNvPr id="8" name="Content Placeholder 7">
@@ -16743,221 +16889,6 @@
       </p:transition>
     </mc:Fallback>
   </mc:AlternateContent>
-</p:sld>
-</file>
-
-<file path=ppt/slides/slide27.xml><?xml version="1.0" encoding="utf-8"?>
-<p:sld xmlns:a="http://schemas.openxmlformats.org/drawingml/2006/main" xmlns:r="http://schemas.openxmlformats.org/officeDocument/2006/relationships" xmlns:p="http://schemas.openxmlformats.org/presentationml/2006/main">
-  <p:cSld>
-    <p:spTree>
-      <p:nvGrpSpPr>
-        <p:cNvPr id="1" name=""/>
-        <p:cNvGrpSpPr/>
-        <p:nvPr/>
-      </p:nvGrpSpPr>
-      <p:grpSpPr>
-        <a:xfrm>
-          <a:off x="0" y="0"/>
-          <a:ext cx="0" cy="0"/>
-          <a:chOff x="0" y="0"/>
-          <a:chExt cx="0" cy="0"/>
-        </a:xfrm>
-      </p:grpSpPr>
-      <p:sp>
-        <p:nvSpPr>
-          <p:cNvPr id="3" name="Content Placeholder 2">
-            <a:extLst>
-              <a:ext uri="{FF2B5EF4-FFF2-40B4-BE49-F238E27FC236}">
-                <a16:creationId xmlns:a16="http://schemas.microsoft.com/office/drawing/2014/main" id="{DCA0730A-77BF-1B8D-5376-F6DCE604B7BB}"/>
-              </a:ext>
-            </a:extLst>
-          </p:cNvPr>
-          <p:cNvSpPr>
-            <a:spLocks noGrp="1"/>
-          </p:cNvSpPr>
-          <p:nvPr>
-            <p:ph sz="half" idx="1"/>
-          </p:nvPr>
-        </p:nvSpPr>
-        <p:spPr/>
-        <p:txBody>
-          <a:bodyPr/>
-          <a:lstStyle/>
-          <a:p>
-            <a:r>
-              <a:rPr lang="en-US" dirty="0"/>
-              <a:t>In addition to the ROC curve and the AUC, the performance of a classifier can be characterized with several other numbers including:</a:t>
-            </a:r>
-          </a:p>
-          <a:p>
-            <a:pPr lvl="1"/>
-            <a:r>
-              <a:rPr lang="en-US" dirty="0"/>
-              <a:t>False Negatives (FN)</a:t>
-            </a:r>
-          </a:p>
-          <a:p>
-            <a:pPr lvl="1"/>
-            <a:r>
-              <a:rPr lang="en-US" dirty="0"/>
-              <a:t>True Positives	(TP)</a:t>
-            </a:r>
-          </a:p>
-          <a:p>
-            <a:pPr lvl="1"/>
-            <a:r>
-              <a:rPr lang="en-US" dirty="0"/>
-              <a:t>True Negatives 	(TN)</a:t>
-            </a:r>
-          </a:p>
-          <a:p>
-            <a:pPr lvl="1"/>
-            <a:r>
-              <a:rPr lang="en-US" dirty="0"/>
-              <a:t>False Positives	(FP)</a:t>
-            </a:r>
-            <a:br>
-              <a:rPr lang="en-US" dirty="0"/>
-            </a:br>
-            <a:endParaRPr lang="en-US" dirty="0"/>
-          </a:p>
-          <a:p>
-            <a:r>
-              <a:rPr lang="en-US" dirty="0"/>
-              <a:t>A classifier can be repurposed in many ways, including as a probability density estimator.</a:t>
-            </a:r>
-          </a:p>
-        </p:txBody>
-      </p:sp>
-      <p:sp>
-        <p:nvSpPr>
-          <p:cNvPr id="2" name="Title 1">
-            <a:extLst>
-              <a:ext uri="{FF2B5EF4-FFF2-40B4-BE49-F238E27FC236}">
-                <a16:creationId xmlns:a16="http://schemas.microsoft.com/office/drawing/2014/main" id="{4B31FE53-CCD3-2FB4-0B9D-BDDBD7ADB3B9}"/>
-              </a:ext>
-            </a:extLst>
-          </p:cNvPr>
-          <p:cNvSpPr>
-            <a:spLocks noGrp="1"/>
-          </p:cNvSpPr>
-          <p:nvPr>
-            <p:ph type="title"/>
-          </p:nvPr>
-        </p:nvSpPr>
-        <p:spPr/>
-        <p:txBody>
-          <a:bodyPr/>
-          <a:lstStyle/>
-          <a:p>
-            <a:r>
-              <a:rPr lang="en-US" dirty="0"/>
-              <a:t>Summary</a:t>
-            </a:r>
-          </a:p>
-        </p:txBody>
-      </p:sp>
-    </p:spTree>
-    <p:extLst>
-      <p:ext uri="{BB962C8B-B14F-4D97-AF65-F5344CB8AC3E}">
-        <p14:creationId xmlns:p14="http://schemas.microsoft.com/office/powerpoint/2010/main" val="1190940371"/>
-      </p:ext>
-    </p:extLst>
-  </p:cSld>
-  <p:clrMapOvr>
-    <a:masterClrMapping/>
-  </p:clrMapOvr>
-  <p:timing>
-    <p:tnLst>
-      <p:par>
-        <p:cTn id="1" dur="indefinite" restart="never" nodeType="tmRoot">
-          <p:childTnLst>
-            <p:seq concurrent="1" nextAc="seek">
-              <p:cTn id="2" dur="indefinite" nodeType="mainSeq">
-                <p:childTnLst>
-                  <p:par>
-                    <p:cTn id="3" fill="hold">
-                      <p:stCondLst>
-                        <p:cond delay="indefinite"/>
-                      </p:stCondLst>
-                      <p:childTnLst>
-                        <p:par>
-                          <p:cTn id="4" fill="hold">
-                            <p:stCondLst>
-                              <p:cond delay="0"/>
-                            </p:stCondLst>
-                            <p:childTnLst>
-                              <p:par>
-                                <p:cTn id="5" presetID="10" presetClass="entr" presetSubtype="0" fill="hold" nodeType="clickEffect">
-                                  <p:stCondLst>
-                                    <p:cond delay="0"/>
-                                  </p:stCondLst>
-                                  <p:childTnLst>
-                                    <p:set>
-                                      <p:cBhvr>
-                                        <p:cTn id="6" dur="1" fill="hold">
-                                          <p:stCondLst>
-                                            <p:cond delay="0"/>
-                                          </p:stCondLst>
-                                        </p:cTn>
-                                        <p:tgtEl>
-                                          <p:spTgt spid="3">
-                                            <p:txEl>
-                                              <p:pRg st="5" end="5"/>
-                                            </p:txEl>
-                                          </p:spTgt>
-                                        </p:tgtEl>
-                                        <p:attrNameLst>
-                                          <p:attrName>style.visibility</p:attrName>
-                                        </p:attrNameLst>
-                                      </p:cBhvr>
-                                      <p:to>
-                                        <p:strVal val="visible"/>
-                                      </p:to>
-                                    </p:set>
-                                    <p:animEffect transition="in" filter="fade">
-                                      <p:cBhvr>
-                                        <p:cTn id="7" dur="500"/>
-                                        <p:tgtEl>
-                                          <p:spTgt spid="3">
-                                            <p:txEl>
-                                              <p:pRg st="5" end="5"/>
-                                            </p:txEl>
-                                          </p:spTgt>
-                                        </p:tgtEl>
-                                      </p:cBhvr>
-                                    </p:animEffect>
-                                  </p:childTnLst>
-                                </p:cTn>
-                              </p:par>
-                            </p:childTnLst>
-                          </p:cTn>
-                        </p:par>
-                      </p:childTnLst>
-                    </p:cTn>
-                  </p:par>
-                </p:childTnLst>
-              </p:cTn>
-              <p:prevCondLst>
-                <p:cond evt="onPrev" delay="0">
-                  <p:tgtEl>
-                    <p:sldTgt/>
-                  </p:tgtEl>
-                </p:cond>
-              </p:prevCondLst>
-              <p:nextCondLst>
-                <p:cond evt="onNext" delay="0">
-                  <p:tgtEl>
-                    <p:sldTgt/>
-                  </p:tgtEl>
-                </p:cond>
-              </p:nextCondLst>
-            </p:seq>
-          </p:childTnLst>
-        </p:cTn>
-      </p:par>
-    </p:tnLst>
-  </p:timing>
 </p:sld>
 </file>
 
@@ -20737,8 +20668,8 @@
           <a:chExt cx="0" cy="0"/>
         </a:xfrm>
       </p:grpSpPr>
-      <mc:AlternateContent xmlns:mc="http://schemas.openxmlformats.org/markup-compatibility/2006">
-        <mc:Choice xmlns:a14="http://schemas.microsoft.com/office/drawing/2010/main" Requires="a14">
+      <mc:AlternateContent xmlns:mc="http://schemas.openxmlformats.org/markup-compatibility/2006" xmlns:a14="http://schemas.microsoft.com/office/drawing/2010/main">
+        <mc:Choice Requires="a14">
           <p:sp>
             <p:nvSpPr>
               <p:cNvPr id="4" name="Content Placeholder 3">
@@ -21513,7 +21444,7 @@
             </p:txBody>
           </p:sp>
         </mc:Choice>
-        <mc:Fallback>
+        <mc:Fallback xmlns="">
           <p:sp>
             <p:nvSpPr>
               <p:cNvPr id="4" name="Content Placeholder 3">

</xml_diff>